<commit_message>
Complete final BAIF demo readiness audit
</commit_message>
<xml_diff>
--- a/submission/VaaniSetu_Final_Hackathon_Deck.pptx
+++ b/submission/VaaniSetu_Final_Hackathon_Deck.pptx
@@ -2,17 +2,17 @@
 <file path=ppt/presentation.xml><?xml version="1.0" encoding="utf-8"?>
 <p:presentation xmlns:p="http://schemas.openxmlformats.org/presentationml/2006/main">
   <p:sldMasterIdLst>
-    <p:sldMasterId xmlns:r="http://schemas.openxmlformats.org/officeDocument/2006/relationships" id="2147483648" r:id="R2b4b0070b5594430"/>
+    <p:sldMasterId xmlns:r="http://schemas.openxmlformats.org/officeDocument/2006/relationships" id="2147483648" r:id="R21cadaa815ef4b34"/>
   </p:sldMasterIdLst>
   <p:notesMasterIdLst>
-    <p:notesMasterId xmlns:r="http://schemas.openxmlformats.org/officeDocument/2006/relationships" r:id="R0594ba7e5edd44be"/>
+    <p:notesMasterId xmlns:r="http://schemas.openxmlformats.org/officeDocument/2006/relationships" r:id="Rfc86f26acf164e9a"/>
   </p:notesMasterIdLst>
   <p:sldIdLst>
-    <p:sldId xmlns:r="http://schemas.openxmlformats.org/officeDocument/2006/relationships" id="256" r:id="Refb857bad6314e7c"/>
-    <p:sldId xmlns:r="http://schemas.openxmlformats.org/officeDocument/2006/relationships" id="257" r:id="R3027833821a54d6a"/>
-    <p:sldId xmlns:r="http://schemas.openxmlformats.org/officeDocument/2006/relationships" id="258" r:id="Rdb8480efe4054f67"/>
-    <p:sldId xmlns:r="http://schemas.openxmlformats.org/officeDocument/2006/relationships" id="259" r:id="R934b34e4f2f04adf"/>
-    <p:sldId xmlns:r="http://schemas.openxmlformats.org/officeDocument/2006/relationships" id="260" r:id="R1d4ff854c20949da"/>
+    <p:sldId xmlns:r="http://schemas.openxmlformats.org/officeDocument/2006/relationships" id="256" r:id="R42ab64f6bf774cb4"/>
+    <p:sldId xmlns:r="http://schemas.openxmlformats.org/officeDocument/2006/relationships" id="257" r:id="R21f3d7bc185b4080"/>
+    <p:sldId xmlns:r="http://schemas.openxmlformats.org/officeDocument/2006/relationships" id="258" r:id="R7e1a45f72f8042ec"/>
+    <p:sldId xmlns:r="http://schemas.openxmlformats.org/officeDocument/2006/relationships" id="259" r:id="R362ebf873af94068"/>
+    <p:sldId xmlns:r="http://schemas.openxmlformats.org/officeDocument/2006/relationships" id="260" r:id="R4cef3ecc9a4c4f09"/>
   </p:sldIdLst>
   <p:sldSz cx="12192000" cy="6858000"/>
   <p:notesSz cx="6858000" cy="9144000"/>
@@ -451,12 +451,12 @@
           </a:p>
           <a:p xmlns:a="http://schemas.openxmlformats.org/drawingml/2006/main">
             <a:r>
-              <a:t>- BAIF organiser guidance, 26 Jun–16 Jul 2026 (screenshots supplied with the repository task)</a:t>
-            </a:r>
-          </a:p>
-          <a:p xmlns:a="http://schemas.openxmlformats.org/drawingml/2006/main">
-            <a:r>
-              <a:t>- README.md and HACKATHON_REQUIREMENTS_AUDIT.md, accessed 28 Jul 2026</a:t>
+              <a:t>- BAIF organiser communications supplied for the final audit (26 May–22 Aug 2026)</a:t>
+            </a:r>
+          </a:p>
+          <a:p xmlns:a="http://schemas.openxmlformats.org/drawingml/2006/main">
+            <a:r>
+              <a:t>- README.md and AUDIT.md, verified 22 Aug 2026</a:t>
             </a:r>
           </a:p>
           <a:p xmlns:a="http://schemas.openxmlformats.org/drawingml/2006/main">
@@ -536,12 +536,12 @@
           </a:p>
           <a:p xmlns:a="http://schemas.openxmlformats.org/drawingml/2006/main">
             <a:r>
-              <a:t>- USER_GUIDE.md and frontend/index.html, accessed 28 Jul 2026</a:t>
-            </a:r>
-          </a:p>
-          <a:p xmlns:a="http://schemas.openxmlformats.org/drawingml/2006/main">
-            <a:r>
-              <a:t>- tests/test_core.py and tests/test_adversarial.py, accessed 28 Jul 2026</a:t>
+              <a:t>- USAGE.md and frontend/index.html, verified 22 Aug 2026</a:t>
+            </a:r>
+          </a:p>
+          <a:p xmlns:a="http://schemas.openxmlformats.org/drawingml/2006/main">
+            <a:r>
+              <a:t>- tests/test_core.py and tests/test_adversarial.py, verified 22 Aug 2026</a:t>
             </a:r>
           </a:p>
           <a:p xmlns:a="http://schemas.openxmlformats.org/drawingml/2006/main">
@@ -621,12 +621,12 @@
           </a:p>
           <a:p xmlns:a="http://schemas.openxmlformats.org/drawingml/2006/main">
             <a:r>
-              <a:t>- BAIF_ARCHITECTURE_NOTE.md and DELIVERY_COMPATIBILITY.md, accessed 28 Jul 2026</a:t>
-            </a:r>
-          </a:p>
-          <a:p xmlns:a="http://schemas.openxmlformats.org/drawingml/2006/main">
-            <a:r>
-              <a:t>- requirements.txt and core/, accessed 28 Jul 2026</a:t>
+              <a:t>- ARCHITECTURE.md, COMPATIBILITY.md and requirements.txt, verified 22 Aug 2026</a:t>
+            </a:r>
+          </a:p>
+          <a:p xmlns:a="http://schemas.openxmlformats.org/drawingml/2006/main">
+            <a:r>
+              <a:t>- BAIF target-environment clarification supplied for the final audit</a:t>
             </a:r>
           </a:p>
           <a:p xmlns:a="http://schemas.openxmlformats.org/drawingml/2006/main">
@@ -706,12 +706,12 @@
           </a:p>
           <a:p xmlns:a="http://schemas.openxmlformats.org/drawingml/2006/main">
             <a:r>
-              <a:t>- TEST_EVIDENCE.md and RELEASE_CHECKLIST.md, accessed 28 Jul 2026</a:t>
-            </a:r>
-          </a:p>
-          <a:p xmlns:a="http://schemas.openxmlformats.org/drawingml/2006/main">
-            <a:r>
-              <a:t>- Local verification: 69 automated tests, 28 Jul 2026</a:t>
+              <a:t>- TESTING.md, tests/test_core.py and tests/test_adversarial.py, verified 22 Aug 2026</a:t>
+            </a:r>
+          </a:p>
+          <a:p xmlns:a="http://schemas.openxmlformats.org/drawingml/2006/main">
+            <a:r>
+              <a:t>- Local verification: 77 automated tests and six translation directions passed, 22 Aug 2026</a:t>
             </a:r>
           </a:p>
           <a:p xmlns:a="http://schemas.openxmlformats.org/drawingml/2006/main">
@@ -791,12 +791,12 @@
           </a:p>
           <a:p xmlns:a="http://schemas.openxmlformats.org/drawingml/2006/main">
             <a:r>
-              <a:t>- IMPLEMENTATION_ROADMAP.md, HANDOVER.md and UAT.md, accessed 28 Jul 2026</a:t>
-            </a:r>
-          </a:p>
-          <a:p xmlns:a="http://schemas.openxmlformats.org/drawingml/2006/main">
-            <a:r>
-              <a:t>- BAIF organiser target-environment guidance supplied with the task</a:t>
+              <a:t>- ACCEPTANCE.md, HANDOVER.md and SETUP.md, verified 22 Aug 2026</a:t>
+            </a:r>
+          </a:p>
+          <a:p xmlns:a="http://schemas.openxmlformats.org/drawingml/2006/main">
+            <a:r>
+              <a:t>- BAIF implementation-review criteria and target-environment guidance supplied for the final audit</a:t>
             </a:r>
           </a:p>
           <a:p xmlns:a="http://schemas.openxmlformats.org/drawingml/2006/main">
@@ -869,7 +869,7 @@
   </p:cSld>
   <p:clrMap bg1="lt1" tx1="dk1" bg2="lt2" tx2="dk2" accent1="accent1" accent2="accent2" accent3="accent3" accent4="accent4" accent5="accent5" accent6="accent6" hlink="hlink" folHlink="folHlink"/>
   <p:sldLayoutIdLst>
-    <p:sldLayoutId xmlns:r="http://schemas.openxmlformats.org/officeDocument/2006/relationships" id="2147483649" r:id="Racf8a96882ea4296"/>
+    <p:sldLayoutId xmlns:r="http://schemas.openxmlformats.org/officeDocument/2006/relationships" id="2147483649" r:id="R8ff7a402ea974aa7"/>
   </p:sldLayoutIdLst>
   <p:txStyles>
     <p:titleStyle>
@@ -5914,7 +5914,7 @@
                   <a:srgbClr val="17212B"/>
                 </a:solidFill>
               </a:rPr>
-              <a:t>69 automated tests pass cleanly.</a:t>
+              <a:t>Automated suite passes cleanly.</a:t>
             </a:r>
           </a:p>
         </p:txBody>
@@ -6980,7 +6980,7 @@
                   <a:srgbClr val="17212B"/>
                 </a:solidFill>
               </a:rPr>
-              <a:t>Numbers, units, URLs and email preservation · target-script and terminology checks · model provenance · versioned corrections · checksum tamper rejection.</a:t>
+              <a:t>Preservation · script/terminology · provenance · versioning · checksum verification.</a:t>
             </a:r>
           </a:p>
         </p:txBody>

</xml_diff>

<commit_message>
Finalize September demo readiness
</commit_message>
<xml_diff>
--- a/submission/VaaniSetu_Final_Hackathon_Deck.pptx
+++ b/submission/VaaniSetu_Final_Hackathon_Deck.pptx
@@ -2,17 +2,17 @@
 <file path=ppt/presentation.xml><?xml version="1.0" encoding="utf-8"?>
 <p:presentation xmlns:p="http://schemas.openxmlformats.org/presentationml/2006/main">
   <p:sldMasterIdLst>
-    <p:sldMasterId xmlns:r="http://schemas.openxmlformats.org/officeDocument/2006/relationships" id="2147483648" r:id="R21cadaa815ef4b34"/>
+    <p:sldMasterId xmlns:r="http://schemas.openxmlformats.org/officeDocument/2006/relationships" id="2147483648" r:id="R1fbb993e5dbd46aa"/>
   </p:sldMasterIdLst>
   <p:notesMasterIdLst>
-    <p:notesMasterId xmlns:r="http://schemas.openxmlformats.org/officeDocument/2006/relationships" r:id="Rfc86f26acf164e9a"/>
+    <p:notesMasterId xmlns:r="http://schemas.openxmlformats.org/officeDocument/2006/relationships" r:id="Rea557abb14fe42ac"/>
   </p:notesMasterIdLst>
   <p:sldIdLst>
-    <p:sldId xmlns:r="http://schemas.openxmlformats.org/officeDocument/2006/relationships" id="256" r:id="R42ab64f6bf774cb4"/>
-    <p:sldId xmlns:r="http://schemas.openxmlformats.org/officeDocument/2006/relationships" id="257" r:id="R21f3d7bc185b4080"/>
-    <p:sldId xmlns:r="http://schemas.openxmlformats.org/officeDocument/2006/relationships" id="258" r:id="R7e1a45f72f8042ec"/>
-    <p:sldId xmlns:r="http://schemas.openxmlformats.org/officeDocument/2006/relationships" id="259" r:id="R362ebf873af94068"/>
-    <p:sldId xmlns:r="http://schemas.openxmlformats.org/officeDocument/2006/relationships" id="260" r:id="R4cef3ecc9a4c4f09"/>
+    <p:sldId xmlns:r="http://schemas.openxmlformats.org/officeDocument/2006/relationships" id="256" r:id="R54531b64f7544b61"/>
+    <p:sldId xmlns:r="http://schemas.openxmlformats.org/officeDocument/2006/relationships" id="257" r:id="R3a815ee2ffb44907"/>
+    <p:sldId xmlns:r="http://schemas.openxmlformats.org/officeDocument/2006/relationships" id="258" r:id="Rf6d145ca66d6418f"/>
+    <p:sldId xmlns:r="http://schemas.openxmlformats.org/officeDocument/2006/relationships" id="259" r:id="Red7438998b094999"/>
+    <p:sldId xmlns:r="http://schemas.openxmlformats.org/officeDocument/2006/relationships" id="260" r:id="R0b4e6c8c0c234f9e"/>
   </p:sldIdLst>
   <p:sldSz cx="12192000" cy="6858000"/>
   <p:notesSz cx="6858000" cy="9144000"/>
@@ -791,12 +791,17 @@
           </a:p>
           <a:p xmlns:a="http://schemas.openxmlformats.org/drawingml/2006/main">
             <a:r>
-              <a:t>- ACCEPTANCE.md, HANDOVER.md and SETUP.md, verified 22 Aug 2026</a:t>
-            </a:r>
-          </a:p>
-          <a:p xmlns:a="http://schemas.openxmlformats.org/drawingml/2006/main">
-            <a:r>
-              <a:t>- BAIF implementation-review criteria and target-environment guidance supplied for the final audit</a:t>
+              <a:t>- Bhashini API documentation, “Overall Understanding”: https://dibd-bhashini.gitbook.io/bhashini-apis</a:t>
+            </a:r>
+          </a:p>
+          <a:p xmlns:a="http://schemas.openxmlformats.org/drawingml/2006/main">
+            <a:r>
+              <a:t>- Bhashini API documentation, “Pipeline Compute Call”: https://dibd-bhashini.gitbook.io/bhashini-apis/pipeline-compute-call</a:t>
+            </a:r>
+          </a:p>
+          <a:p xmlns:a="http://schemas.openxmlformats.org/drawingml/2006/main">
+            <a:r>
+              <a:t>- VaaniSetu README.md, AUDIT.md and TESTING.md, verified 1 Sep 2026</a:t>
             </a:r>
           </a:p>
           <a:p xmlns:a="http://schemas.openxmlformats.org/drawingml/2006/main">
@@ -869,7 +874,7 @@
   </p:cSld>
   <p:clrMap bg1="lt1" tx1="dk1" bg2="lt2" tx2="dk2" accent1="accent1" accent2="accent2" accent3="accent3" accent4="accent4" accent5="accent5" accent6="accent6" hlink="hlink" folHlink="folHlink"/>
   <p:sldLayoutIdLst>
-    <p:sldLayoutId xmlns:r="http://schemas.openxmlformats.org/officeDocument/2006/relationships" id="2147483649" r:id="R8ff7a402ea974aa7"/>
+    <p:sldLayoutId xmlns:r="http://schemas.openxmlformats.org/officeDocument/2006/relationships" id="2147483649" r:id="R70c868133f594e6d"/>
   </p:sldLayoutIdLst>
   <p:txStyles>
     <p:titleStyle>
@@ -7193,7 +7198,7 @@
                   <a:srgbClr val="126C66"/>
                 </a:solidFill>
               </a:rPr>
-              <a:t>SUBMISSION READY</a:t>
+              <a:t>BEST-FIT DIFFERENTIATION</a:t>
             </a:r>
           </a:p>
         </p:txBody>
@@ -7244,7 +7249,7 @@
                   <a:srgbClr val="17212B"/>
                 </a:solidFill>
               </a:rPr>
-              <a:t>Ready to demonstrate tomorrow—honest about the last three gates</a:t>
+              <a:t>Built for BAIF’s workflow—not an unproven model claim</a:t>
             </a:r>
           </a:p>
         </p:txBody>
@@ -7295,7 +7300,7 @@
                   <a:srgbClr val="637083"/>
                 </a:solidFill>
               </a:rPr>
-              <a:t>All independent engineering and submission work is packaged; external acceptance stays explicit.</a:t>
+              <a:t>Bhashini offers breadth; VaaniSetu operationalises review, reuse and offline field delivery.</a:t>
             </a:r>
           </a:p>
         </p:txBody>
@@ -7393,7 +7398,7 @@
                   <a:srgbClr val="FFFFFF"/>
                 </a:solidFill>
               </a:rPr>
-              <a:t>PRODUCT</a:t>
+              <a:t>BHASHINI</a:t>
             </a:r>
           </a:p>
         </p:txBody>
@@ -7444,7 +7449,7 @@
                   <a:srgbClr val="17212B"/>
                 </a:solidFill>
               </a:rPr>
-              <a:t>Complete workflow</a:t>
+              <a:t>Breadth &amp; APIs</a:t>
             </a:r>
           </a:p>
         </p:txBody>
@@ -7495,7 +7500,7 @@
                   <a:srgbClr val="637083"/>
                 </a:solidFill>
               </a:rPr>
-              <a:t>Text, documents, audio/video, review, reuse and offline delivery.</a:t>
+              <a:t>Broad Indian-language model and API ecosystem.</a:t>
             </a:r>
           </a:p>
         </p:txBody>
@@ -7593,7 +7598,7 @@
                   <a:srgbClr val="8A5A00"/>
                 </a:solidFill>
               </a:rPr>
-              <a:t>PROOF</a:t>
+              <a:t>LOCAL</a:t>
             </a:r>
           </a:p>
         </p:txBody>
@@ -7644,7 +7649,7 @@
                   <a:srgbClr val="17212B"/>
                 </a:solidFill>
               </a:rPr>
-              <a:t>Release candidate</a:t>
+              <a:t>Controlled workflow</a:t>
             </a:r>
           </a:p>
         </p:txBody>
@@ -7695,7 +7700,7 @@
                   <a:srgbClr val="637083"/>
                 </a:solidFill>
               </a:rPr>
-              <a:t>Tests, browser/media/stress evidence and verified packages.</a:t>
+              <a:t>Human review, exact reuse and verified offline packages.</a:t>
             </a:r>
           </a:p>
         </p:txBody>
@@ -7793,7 +7798,7 @@
                   <a:srgbClr val="9D3E2B"/>
                 </a:solidFill>
               </a:rPr>
-              <a:t>OPS</a:t>
+              <a:t>CLAIMS</a:t>
             </a:r>
           </a:p>
         </p:txBody>
@@ -7844,7 +7849,7 @@
                   <a:srgbClr val="17212B"/>
                 </a:solidFill>
               </a:rPr>
-              <a:t>BAIF-operable</a:t>
+              <a:t>Honest evidence</a:t>
             </a:r>
           </a:p>
         </p:txBody>
@@ -7895,7 +7900,7 @@
                   <a:srgbClr val="637083"/>
                 </a:solidFill>
               </a:rPr>
-              <a:t>Windows setup, preflight, backup, UAT and guides.</a:t>
+              <a:t>No measured quality or latency uplift is claimed.</a:t>
             </a:r>
           </a:p>
         </p:txBody>
@@ -7952,7 +7957,7 @@
                   <a:srgbClr val="FFFFFF"/>
                 </a:solidFill>
               </a:rPr>
-              <a:t>External acceptance kept visible</a:t>
+              <a:t>Why it matters to BAIF</a:t>
             </a:r>
           </a:p>
           <a:p xmlns:a="http://schemas.openxmlformats.org/drawingml/2006/main">
@@ -7970,7 +7975,7 @@
                   <a:srgbClr val="FFFFFF"/>
                 </a:solidFill>
               </a:rPr>
-              <a:t>IndicTrans2 terms/cache · Hindi/Marathi reviewer sign-off · clean Windows 11 baseline proof.</a:t>
+              <a:t>Privacy, provenance, review, recovery and reuse surround every translation.</a:t>
             </a:r>
           </a:p>
         </p:txBody>
@@ -8033,7 +8038,7 @@
                   <a:srgbClr val="17212B"/>
                 </a:solidFill>
               </a:rPr>
-              <a:t>No hidden dependency</a:t>
+              <a:t>Best-fit choice</a:t>
             </a:r>
           </a:p>
           <a:p xmlns:a="http://schemas.openxmlformats.org/drawingml/2006/main">
@@ -8051,7 +8056,7 @@
                   <a:srgbClr val="17212B"/>
                 </a:solidFill>
               </a:rPr>
-              <a:t>Normal jobs stay local; production acceptance waits only for the three named gates.</a:t>
+              <a:t>Bhashini for breadth; VaaniSetu for controlled office-to-field operations.</a:t>
             </a:r>
           </a:p>
         </p:txBody>
@@ -8184,7 +8189,7 @@
                   <a:srgbClr val="0D4F4B"/>
                 </a:solidFill>
               </a:rPr>
-              <a:t>VaaniSetu makes translated knowledge trustworthy, reusable and reachable—office to field.</a:t>
+              <a:t>VaaniSetu turns translation into a governed, reusable BAIF content operation.</a:t>
             </a:r>
           </a:p>
         </p:txBody>

</xml_diff>

<commit_message>
Finalize September demo readiness (#4)
</commit_message>
<xml_diff>
--- a/submission/VaaniSetu_Final_Hackathon_Deck.pptx
+++ b/submission/VaaniSetu_Final_Hackathon_Deck.pptx
@@ -2,17 +2,17 @@
 <file path=ppt/presentation.xml><?xml version="1.0" encoding="utf-8"?>
 <p:presentation xmlns:p="http://schemas.openxmlformats.org/presentationml/2006/main">
   <p:sldMasterIdLst>
-    <p:sldMasterId xmlns:r="http://schemas.openxmlformats.org/officeDocument/2006/relationships" id="2147483648" r:id="R21cadaa815ef4b34"/>
+    <p:sldMasterId xmlns:r="http://schemas.openxmlformats.org/officeDocument/2006/relationships" id="2147483648" r:id="R1fbb993e5dbd46aa"/>
   </p:sldMasterIdLst>
   <p:notesMasterIdLst>
-    <p:notesMasterId xmlns:r="http://schemas.openxmlformats.org/officeDocument/2006/relationships" r:id="Rfc86f26acf164e9a"/>
+    <p:notesMasterId xmlns:r="http://schemas.openxmlformats.org/officeDocument/2006/relationships" r:id="Rea557abb14fe42ac"/>
   </p:notesMasterIdLst>
   <p:sldIdLst>
-    <p:sldId xmlns:r="http://schemas.openxmlformats.org/officeDocument/2006/relationships" id="256" r:id="R42ab64f6bf774cb4"/>
-    <p:sldId xmlns:r="http://schemas.openxmlformats.org/officeDocument/2006/relationships" id="257" r:id="R21f3d7bc185b4080"/>
-    <p:sldId xmlns:r="http://schemas.openxmlformats.org/officeDocument/2006/relationships" id="258" r:id="R7e1a45f72f8042ec"/>
-    <p:sldId xmlns:r="http://schemas.openxmlformats.org/officeDocument/2006/relationships" id="259" r:id="R362ebf873af94068"/>
-    <p:sldId xmlns:r="http://schemas.openxmlformats.org/officeDocument/2006/relationships" id="260" r:id="R4cef3ecc9a4c4f09"/>
+    <p:sldId xmlns:r="http://schemas.openxmlformats.org/officeDocument/2006/relationships" id="256" r:id="R54531b64f7544b61"/>
+    <p:sldId xmlns:r="http://schemas.openxmlformats.org/officeDocument/2006/relationships" id="257" r:id="R3a815ee2ffb44907"/>
+    <p:sldId xmlns:r="http://schemas.openxmlformats.org/officeDocument/2006/relationships" id="258" r:id="Rf6d145ca66d6418f"/>
+    <p:sldId xmlns:r="http://schemas.openxmlformats.org/officeDocument/2006/relationships" id="259" r:id="Red7438998b094999"/>
+    <p:sldId xmlns:r="http://schemas.openxmlformats.org/officeDocument/2006/relationships" id="260" r:id="R0b4e6c8c0c234f9e"/>
   </p:sldIdLst>
   <p:sldSz cx="12192000" cy="6858000"/>
   <p:notesSz cx="6858000" cy="9144000"/>
@@ -791,12 +791,17 @@
           </a:p>
           <a:p xmlns:a="http://schemas.openxmlformats.org/drawingml/2006/main">
             <a:r>
-              <a:t>- ACCEPTANCE.md, HANDOVER.md and SETUP.md, verified 22 Aug 2026</a:t>
-            </a:r>
-          </a:p>
-          <a:p xmlns:a="http://schemas.openxmlformats.org/drawingml/2006/main">
-            <a:r>
-              <a:t>- BAIF implementation-review criteria and target-environment guidance supplied for the final audit</a:t>
+              <a:t>- Bhashini API documentation, “Overall Understanding”: https://dibd-bhashini.gitbook.io/bhashini-apis</a:t>
+            </a:r>
+          </a:p>
+          <a:p xmlns:a="http://schemas.openxmlformats.org/drawingml/2006/main">
+            <a:r>
+              <a:t>- Bhashini API documentation, “Pipeline Compute Call”: https://dibd-bhashini.gitbook.io/bhashini-apis/pipeline-compute-call</a:t>
+            </a:r>
+          </a:p>
+          <a:p xmlns:a="http://schemas.openxmlformats.org/drawingml/2006/main">
+            <a:r>
+              <a:t>- VaaniSetu README.md, AUDIT.md and TESTING.md, verified 1 Sep 2026</a:t>
             </a:r>
           </a:p>
           <a:p xmlns:a="http://schemas.openxmlformats.org/drawingml/2006/main">
@@ -869,7 +874,7 @@
   </p:cSld>
   <p:clrMap bg1="lt1" tx1="dk1" bg2="lt2" tx2="dk2" accent1="accent1" accent2="accent2" accent3="accent3" accent4="accent4" accent5="accent5" accent6="accent6" hlink="hlink" folHlink="folHlink"/>
   <p:sldLayoutIdLst>
-    <p:sldLayoutId xmlns:r="http://schemas.openxmlformats.org/officeDocument/2006/relationships" id="2147483649" r:id="R8ff7a402ea974aa7"/>
+    <p:sldLayoutId xmlns:r="http://schemas.openxmlformats.org/officeDocument/2006/relationships" id="2147483649" r:id="R70c868133f594e6d"/>
   </p:sldLayoutIdLst>
   <p:txStyles>
     <p:titleStyle>
@@ -7193,7 +7198,7 @@
                   <a:srgbClr val="126C66"/>
                 </a:solidFill>
               </a:rPr>
-              <a:t>SUBMISSION READY</a:t>
+              <a:t>BEST-FIT DIFFERENTIATION</a:t>
             </a:r>
           </a:p>
         </p:txBody>
@@ -7244,7 +7249,7 @@
                   <a:srgbClr val="17212B"/>
                 </a:solidFill>
               </a:rPr>
-              <a:t>Ready to demonstrate tomorrow—honest about the last three gates</a:t>
+              <a:t>Built for BAIF’s workflow—not an unproven model claim</a:t>
             </a:r>
           </a:p>
         </p:txBody>
@@ -7295,7 +7300,7 @@
                   <a:srgbClr val="637083"/>
                 </a:solidFill>
               </a:rPr>
-              <a:t>All independent engineering and submission work is packaged; external acceptance stays explicit.</a:t>
+              <a:t>Bhashini offers breadth; VaaniSetu operationalises review, reuse and offline field delivery.</a:t>
             </a:r>
           </a:p>
         </p:txBody>
@@ -7393,7 +7398,7 @@
                   <a:srgbClr val="FFFFFF"/>
                 </a:solidFill>
               </a:rPr>
-              <a:t>PRODUCT</a:t>
+              <a:t>BHASHINI</a:t>
             </a:r>
           </a:p>
         </p:txBody>
@@ -7444,7 +7449,7 @@
                   <a:srgbClr val="17212B"/>
                 </a:solidFill>
               </a:rPr>
-              <a:t>Complete workflow</a:t>
+              <a:t>Breadth &amp; APIs</a:t>
             </a:r>
           </a:p>
         </p:txBody>
@@ -7495,7 +7500,7 @@
                   <a:srgbClr val="637083"/>
                 </a:solidFill>
               </a:rPr>
-              <a:t>Text, documents, audio/video, review, reuse and offline delivery.</a:t>
+              <a:t>Broad Indian-language model and API ecosystem.</a:t>
             </a:r>
           </a:p>
         </p:txBody>
@@ -7593,7 +7598,7 @@
                   <a:srgbClr val="8A5A00"/>
                 </a:solidFill>
               </a:rPr>
-              <a:t>PROOF</a:t>
+              <a:t>LOCAL</a:t>
             </a:r>
           </a:p>
         </p:txBody>
@@ -7644,7 +7649,7 @@
                   <a:srgbClr val="17212B"/>
                 </a:solidFill>
               </a:rPr>
-              <a:t>Release candidate</a:t>
+              <a:t>Controlled workflow</a:t>
             </a:r>
           </a:p>
         </p:txBody>
@@ -7695,7 +7700,7 @@
                   <a:srgbClr val="637083"/>
                 </a:solidFill>
               </a:rPr>
-              <a:t>Tests, browser/media/stress evidence and verified packages.</a:t>
+              <a:t>Human review, exact reuse and verified offline packages.</a:t>
             </a:r>
           </a:p>
         </p:txBody>
@@ -7793,7 +7798,7 @@
                   <a:srgbClr val="9D3E2B"/>
                 </a:solidFill>
               </a:rPr>
-              <a:t>OPS</a:t>
+              <a:t>CLAIMS</a:t>
             </a:r>
           </a:p>
         </p:txBody>
@@ -7844,7 +7849,7 @@
                   <a:srgbClr val="17212B"/>
                 </a:solidFill>
               </a:rPr>
-              <a:t>BAIF-operable</a:t>
+              <a:t>Honest evidence</a:t>
             </a:r>
           </a:p>
         </p:txBody>
@@ -7895,7 +7900,7 @@
                   <a:srgbClr val="637083"/>
                 </a:solidFill>
               </a:rPr>
-              <a:t>Windows setup, preflight, backup, UAT and guides.</a:t>
+              <a:t>No measured quality or latency uplift is claimed.</a:t>
             </a:r>
           </a:p>
         </p:txBody>
@@ -7952,7 +7957,7 @@
                   <a:srgbClr val="FFFFFF"/>
                 </a:solidFill>
               </a:rPr>
-              <a:t>External acceptance kept visible</a:t>
+              <a:t>Why it matters to BAIF</a:t>
             </a:r>
           </a:p>
           <a:p xmlns:a="http://schemas.openxmlformats.org/drawingml/2006/main">
@@ -7970,7 +7975,7 @@
                   <a:srgbClr val="FFFFFF"/>
                 </a:solidFill>
               </a:rPr>
-              <a:t>IndicTrans2 terms/cache · Hindi/Marathi reviewer sign-off · clean Windows 11 baseline proof.</a:t>
+              <a:t>Privacy, provenance, review, recovery and reuse surround every translation.</a:t>
             </a:r>
           </a:p>
         </p:txBody>
@@ -8033,7 +8038,7 @@
                   <a:srgbClr val="17212B"/>
                 </a:solidFill>
               </a:rPr>
-              <a:t>No hidden dependency</a:t>
+              <a:t>Best-fit choice</a:t>
             </a:r>
           </a:p>
           <a:p xmlns:a="http://schemas.openxmlformats.org/drawingml/2006/main">
@@ -8051,7 +8056,7 @@
                   <a:srgbClr val="17212B"/>
                 </a:solidFill>
               </a:rPr>
-              <a:t>Normal jobs stay local; production acceptance waits only for the three named gates.</a:t>
+              <a:t>Bhashini for breadth; VaaniSetu for controlled office-to-field operations.</a:t>
             </a:r>
           </a:p>
         </p:txBody>
@@ -8184,7 +8189,7 @@
                   <a:srgbClr val="0D4F4B"/>
                 </a:solidFill>
               </a:rPr>
-              <a:t>VaaniSetu makes translated knowledge trustworthy, reusable and reachable—office to field.</a:t>
+              <a:t>VaaniSetu turns translation into a governed, reusable BAIF content operation.</a:t>
             </a:r>
           </a:p>
         </p:txBody>

</xml_diff>